<commit_message>
Update the Review III presentation with the final project status
- Conclusion: project complete; free hosting tier restart limitation;
  persistent database added to future work.
- Findings: live-site snapshot of 15 Oct 2026 (57 seeded claims) next
  to the repository figures; test summary records the live check.
- Architecture: the verify-deployment workflow snapshots live claims.
- IMPLEMENTATION_STATUS and release notes 1.4.2.

Co-Authored-By: Claude Opus 5.5 <noreply@anthropic.com>
Claude-Session: https://claude.ai/code/session_01Jt1abTRDHyLt58nbRLKUtK
</commit_message>
<xml_diff>
--- a/docs/presentation/Claim_Sense_Review_III_SK_Sricharan.pptx
+++ b/docs/presentation/Claim_Sense_Review_III_SK_Sricharan.pptx
@@ -7715,6 +7715,38 @@
           <a:p>
             <a:pPr algn="l">
               <a:spcAft>
+                <a:spcPts val="800"/>
+              </a:spcAft>
+            </a:pPr>
+            <a:r>
+              <a:rPr sz="1200" b="0" i="0">
+                <a:solidFill>
+                  <a:srgbClr val="242424"/>
+                </a:solidFill>
+                <a:latin typeface="Calibri"/>
+              </a:rPr>
+              <a:t>Every claim went to a human review queue; the system decided none. Every exclusion, waiting period and limit in the four wordings is exercised by at least one claim.</a:t>
+            </a:r>
+          </a:p>
+          <a:p>
+            <a:pPr algn="l">
+              <a:spcAft>
+                <a:spcPts val="400"/>
+              </a:spcAft>
+            </a:pPr>
+            <a:r>
+              <a:rPr sz="1500" b="1" i="0">
+                <a:solidFill>
+                  <a:srgbClr val="1F3864"/>
+                </a:solidFill>
+                <a:latin typeface="Calibri"/>
+              </a:rPr>
+              <a:t>Live site, 15 Oct 2026</a:t>
+            </a:r>
+          </a:p>
+          <a:p>
+            <a:pPr algn="l">
+              <a:spcAft>
                 <a:spcPts val="0"/>
               </a:spcAft>
             </a:pPr>
@@ -7725,7 +7757,7 @@
                 </a:solidFill>
                 <a:latin typeface="Calibri"/>
               </a:rPr>
-              <a:t>Every claim went to a human review queue; the system decided none. Every exclusion, waiting period and limit in the four wordings is exercised by at least one claim.</a:t>
+              <a:t>57 seeded claims: ₹86.96 L billed, ₹53.41 L payable (61.4%), all awaiting a reviewer. The 58th claim above is the demo upload that the smoke test files.</a:t>
             </a:r>
           </a:p>
         </p:txBody>
@@ -8554,7 +8586,7 @@
                 </a:solidFill>
                 <a:latin typeface="Calibri"/>
               </a:rPr>
-              <a:t>127 backend tests  ·  12 browser tests  ·  live smoke test passed on claim-sense.onrender.com</a:t>
+              <a:t>127 backend tests  ·  12 browser tests  ·  live site checks passed (15 Oct 2026)</a:t>
             </a:r>
           </a:p>
         </p:txBody>
@@ -8867,6 +8899,23 @@
                 </a:solidFill>
                 <a:latin typeface="Calibri"/>
               </a:rPr>
+              <a:t>Project complete: every item in the definition of done is met and verified on the live site.</a:t>
+            </a:r>
+          </a:p>
+          <a:p>
+            <a:pPr algn="l" marL="201168" indent="-201168">
+              <a:spcAft>
+                <a:spcPts val="500"/>
+              </a:spcAft>
+              <a:buChar char="•"/>
+            </a:pPr>
+            <a:r>
+              <a:rPr sz="1500" b="0" i="0">
+                <a:solidFill>
+                  <a:srgbClr val="242424"/>
+                </a:solidFill>
+                <a:latin typeface="Calibri"/>
+              </a:rPr>
               <a:t>A working, deployed claims decision-support system for health, motor, home and travel insurance.</a:t>
             </a:r>
           </a:p>
@@ -8952,6 +9001,23 @@
                 <a:latin typeface="Calibri"/>
               </a:rPr>
               <a:t>Synthetic data only; the LLM narrative is not yet scored; no OCR for scanned images.</a:t>
+            </a:r>
+          </a:p>
+          <a:p>
+            <a:pPr algn="l" marL="201168" indent="-201168">
+              <a:spcAft>
+                <a:spcPts val="500"/>
+              </a:spcAft>
+              <a:buChar char="•"/>
+            </a:pPr>
+            <a:r>
+              <a:rPr sz="1500" b="0" i="0">
+                <a:solidFill>
+                  <a:srgbClr val="242424"/>
+                </a:solidFill>
+                <a:latin typeface="Calibri"/>
+              </a:rPr>
+              <a:t>The free hosting tier restarts with the 57 seeded claims, so claims filed on the live site are not kept.</a:t>
             </a:r>
           </a:p>
         </p:txBody>
@@ -8965,7 +9031,7 @@
         <p:spPr>
           <a:xfrm>
             <a:off x="7315200" y="1417320"/>
-            <a:ext cx="4526280" cy="3291840"/>
+            <a:ext cx="4526280" cy="3749039"/>
           </a:xfrm>
           <a:prstGeom prst="roundRect">
             <a:avLst>
@@ -9096,6 +9162,23 @@
                 <a:latin typeface="Calibri"/>
               </a:rPr>
               <a:t>Azure Container Apps deployment, single sign-on and an ML fraud model</a:t>
+            </a:r>
+          </a:p>
+          <a:p>
+            <a:pPr algn="l" marL="201168" indent="-201168">
+              <a:spcAft>
+                <a:spcPts val="600"/>
+              </a:spcAft>
+              <a:buChar char="•"/>
+            </a:pPr>
+            <a:r>
+              <a:rPr sz="1400" b="0" i="0">
+                <a:solidFill>
+                  <a:srgbClr val="242424"/>
+                </a:solidFill>
+                <a:latin typeface="Calibri"/>
+              </a:rPr>
+              <a:t>Persistent database on a paid hosting tier</a:t>
             </a:r>
           </a:p>
         </p:txBody>
@@ -17553,7 +17636,7 @@
                 </a:solidFill>
                 <a:latin typeface="Calibri"/>
               </a:rPr>
-              <a:t>One Docker image (UI built into the API). GitHub Actions CI. Live on Render with a verify-deployment workflow.</a:t>
+              <a:t>One Docker image (UI built into the API). GitHub Actions CI. Live on Render; a verify-deployment workflow snapshots the live claims and runs the smoke test.</a:t>
             </a:r>
           </a:p>
         </p:txBody>

</xml_diff>

<commit_message>
Refresh the dashboard, deck and screenshots from the live six-line release
The Verify deployment workflow (run 41115415499) passed against the
deployed six-line build: 72 claims, 22,218,600.00 billed and
16,198,470.00 payable, matching the repository's prediction.

- docs/dashboard: claims, deductions, evaluation and portfolio data
  rebuilt from that snapshot; the page lists all six lines and approvals.
- Presentation: figures, module text, the CAS reference and screenshots
  updated; deck rebuilt with build.py.
- README screenshots regenerated with e2e/screenshots.mjs.
- claims_report.py: the portfolio heading shows its real size, and a
  live report notes when the deployment's LLM writes the narrative.
- Status, release notes (1.5.1), changelog and CLAUDE.md updated.

Co-Authored-By: Claude Opus 5.5 <noreply@anthropic.com>
Claude-Session: https://claude.ai/code/session_016fgMV7DHPvG5bwbfrAgtdq
</commit_message>
<xml_diff>
--- a/docs/presentation/Claim_Sense_Review_III_SK_Sricharan.pptx
+++ b/docs/presentation/Claim_Sense_Review_III_SK_Sricharan.pptx
@@ -177,11 +177,11 @@
           </c:spPr>
           <c:cat>
             <c:strRef>
-              <c:f>Sheet1!$A$2:$A$5</c:f>
+              <c:f>Sheet1!$A$2:$A$7</c:f>
               <c:strCache>
-                <c:ptCount val="4"/>
+                <c:ptCount val="6"/>
                 <c:pt idx="0">
-                  <c:v>Health (22)</c:v>
+                  <c:v>Health (21)</c:v>
                 </c:pt>
                 <c:pt idx="1">
                   <c:v>Motor (11)</c:v>
@@ -192,17 +192,23 @@
                 <c:pt idx="3">
                   <c:v>Travel (14)</c:v>
                 </c:pt>
+                <c:pt idx="4">
+                  <c:v>PA (8)</c:v>
+                </c:pt>
+                <c:pt idx="5">
+                  <c:v>Life (7)</c:v>
+                </c:pt>
               </c:strCache>
             </c:strRef>
           </c:cat>
           <c:val>
             <c:numRef>
-              <c:f>Sheet1!$B$2:$B$5</c:f>
+              <c:f>Sheet1!$B$2:$B$7</c:f>
               <c:numCache>
                 <c:formatCode>General</c:formatCode>
-                <c:ptCount val="4"/>
+                <c:ptCount val="6"/>
                 <c:pt idx="0">
-                  <c:v>22.4</c:v>
+                  <c:v>21.62</c:v>
                 </c:pt>
                 <c:pt idx="1">
                   <c:v>6.81</c:v>
@@ -212,6 +218,12 @@
                 </c:pt>
                 <c:pt idx="3">
                   <c:v>29.1</c:v>
+                </c:pt>
+                <c:pt idx="4">
+                  <c:v>28.23</c:v>
+                </c:pt>
+                <c:pt idx="5">
+                  <c:v>107.0</c:v>
                 </c:pt>
               </c:numCache>
             </c:numRef>
@@ -238,11 +250,11 @@
           </c:spPr>
           <c:cat>
             <c:strRef>
-              <c:f>Sheet1!$A$2:$A$5</c:f>
+              <c:f>Sheet1!$A$2:$A$7</c:f>
               <c:strCache>
-                <c:ptCount val="4"/>
+                <c:ptCount val="6"/>
                 <c:pt idx="0">
-                  <c:v>Health (22)</c:v>
+                  <c:v>Health (21)</c:v>
                 </c:pt>
                 <c:pt idx="1">
                   <c:v>Motor (11)</c:v>
@@ -253,17 +265,23 @@
                 <c:pt idx="3">
                   <c:v>Travel (14)</c:v>
                 </c:pt>
+                <c:pt idx="4">
+                  <c:v>PA (8)</c:v>
+                </c:pt>
+                <c:pt idx="5">
+                  <c:v>Life (7)</c:v>
+                </c:pt>
               </c:strCache>
             </c:strRef>
           </c:cat>
           <c:val>
             <c:numRef>
-              <c:f>Sheet1!$C$2:$C$5</c:f>
+              <c:f>Sheet1!$C$2:$C$7</c:f>
               <c:numCache>
                 <c:formatCode>General</c:formatCode>
-                <c:ptCount val="4"/>
+                <c:ptCount val="6"/>
                 <c:pt idx="0">
-                  <c:v>12.55</c:v>
+                  <c:v>11.91</c:v>
                 </c:pt>
                 <c:pt idx="1">
                   <c:v>3.04</c:v>
@@ -273,6 +291,12 @@
                 </c:pt>
                 <c:pt idx="3">
                   <c:v>19.45</c:v>
+                </c:pt>
+                <c:pt idx="4">
+                  <c:v>26.57</c:v>
+                </c:pt>
+                <c:pt idx="5">
+                  <c:v>82.0</c:v>
                 </c:pt>
               </c:numCache>
             </c:numRef>
@@ -6747,7 +6771,7 @@
                 </a:solidFill>
                 <a:latin typeface="Calibri"/>
               </a:rPr>
-              <a:t>Synthetic only: 5 policy wordings (health x2, motor, home, travel)</a:t>
+              <a:t>Synthetic only: 7 policy wordings across 6 lines</a:t>
             </a:r>
           </a:p>
           <a:p>
@@ -6764,7 +6788,7 @@
                 </a:solidFill>
                 <a:latin typeface="Calibri"/>
               </a:rPr>
-              <a:t>58 claim packets; 1,000-claim synthetic portfolio</a:t>
+              <a:t>72 claim packets; 10,000-claim synthetic portfolio</a:t>
             </a:r>
           </a:p>
           <a:p>
@@ -6781,7 +6805,7 @@
                 </a:solidFill>
                 <a:latin typeface="Calibri"/>
               </a:rPr>
-              <a:t>Golden set: 57 claim cases + 26 questions, worked by hand</a:t>
+              <a:t>Golden set: 72 claim cases + 30 questions, worked by hand</a:t>
             </a:r>
           </a:p>
           <a:p>
@@ -6798,7 +6822,7 @@
                 </a:solidFill>
                 <a:latin typeface="Calibri"/>
               </a:rPr>
-              <a:t>Source registry with SHA-256 checksums</a:t>
+              <a:t>SHA-256 source registry; CAS Schedule P industry benchmark (not used in decisions)</a:t>
             </a:r>
           </a:p>
           <a:p>
@@ -7157,7 +7181,7 @@
                 </a:solidFill>
                 <a:latin typeface="Calibri"/>
               </a:rPr>
-              <a:t>58</a:t>
+              <a:t>72</a:t>
             </a:r>
           </a:p>
         </p:txBody>
@@ -7196,7 +7220,7 @@
                 </a:solidFill>
                 <a:latin typeface="Calibri"/>
               </a:rPr>
-              <a:t>claims across 4 lines</a:t>
+              <a:t>claims across 6 lines</a:t>
             </a:r>
           </a:p>
         </p:txBody>
@@ -7281,7 +7305,7 @@
                 </a:solidFill>
                 <a:latin typeface="Calibri"/>
               </a:rPr>
-              <a:t>₹87.74 L</a:t>
+              <a:t>₹2.22 Cr</a:t>
             </a:r>
           </a:p>
         </p:txBody>
@@ -7405,7 +7429,7 @@
                 </a:solidFill>
                 <a:latin typeface="Calibri"/>
               </a:rPr>
-              <a:t>₹54.06 L</a:t>
+              <a:t>₹1.62 Cr</a:t>
             </a:r>
           </a:p>
         </p:txBody>
@@ -7444,7 +7468,7 @@
                 </a:solidFill>
                 <a:latin typeface="Calibri"/>
               </a:rPr>
-              <a:t>recommended payable (61.6%)</a:t>
+              <a:t>recommended payable (72.9%)</a:t>
             </a:r>
           </a:p>
         </p:txBody>
@@ -7529,7 +7553,7 @@
                 </a:solidFill>
                 <a:latin typeface="Calibri"/>
               </a:rPr>
-              <a:t>803/803</a:t>
+              <a:t>986/986</a:t>
             </a:r>
           </a:p>
         </p:txBody>
@@ -7661,7 +7685,7 @@
                 </a:solidFill>
                 <a:latin typeface="Calibri"/>
               </a:rPr>
-              <a:t>Partial approval: 31</a:t>
+              <a:t>Partial approval: 33</a:t>
             </a:r>
           </a:p>
           <a:p>
@@ -7677,7 +7701,7 @@
                 </a:solidFill>
                 <a:latin typeface="Calibri"/>
               </a:rPr>
-              <a:t>Reject with cited clause: 21</a:t>
+              <a:t>Reject with cited clause: 25</a:t>
             </a:r>
           </a:p>
           <a:p>
@@ -7693,7 +7717,7 @@
                 </a:solidFill>
                 <a:latin typeface="Calibri"/>
               </a:rPr>
-              <a:t>Request information: 4</a:t>
+              <a:t>Request information: 6</a:t>
             </a:r>
           </a:p>
           <a:p>
@@ -7709,7 +7733,7 @@
                 </a:solidFill>
                 <a:latin typeface="Calibri"/>
               </a:rPr>
-              <a:t>Investigate: 2</a:t>
+              <a:t>Investigate: 4  ·  Approve: 4</a:t>
             </a:r>
           </a:p>
           <a:p>
@@ -7725,7 +7749,7 @@
                 </a:solidFill>
                 <a:latin typeface="Calibri"/>
               </a:rPr>
-              <a:t>Every claim went to a human review queue; the system decided none. Every exclusion, waiting period and limit in the four wordings is exercised by at least one claim.</a:t>
+              <a:t>Every claim went to a human review queue; the system decided none. Every exclusion, waiting period and limit in the wordings is exercised by at least one claim.</a:t>
             </a:r>
           </a:p>
           <a:p>
@@ -7741,7 +7765,7 @@
                 </a:solidFill>
                 <a:latin typeface="Calibri"/>
               </a:rPr>
-              <a:t>Live site, 15 Oct 2026</a:t>
+              <a:t>Live site, 30 Oct 2026</a:t>
             </a:r>
           </a:p>
           <a:p>
@@ -7757,7 +7781,7 @@
                 </a:solidFill>
                 <a:latin typeface="Calibri"/>
               </a:rPr>
-              <a:t>57 seeded claims: ₹86.96 L billed, ₹53.41 L payable (61.4%), all awaiting a reviewer. The 58th claim above is the demo upload that the smoke test files.</a:t>
+              <a:t>The figures above are the live snapshot. They match the repository's prediction to the rupee, and the smoke test then filed and assessed one new claim on each line.</a:t>
             </a:r>
           </a:p>
         </p:txBody>
@@ -8122,7 +8146,7 @@
                             <a:srgbClr val="242424"/>
                           </a:solidFill>
                         </a:rPr>
-                        <a:t>107/107</a:t>
+                        <a:t>130/130</a:t>
                       </a:r>
                     </a:p>
                   </a:txBody>
@@ -8168,7 +8192,7 @@
                             <a:srgbClr val="242424"/>
                           </a:solidFill>
                         </a:rPr>
-                        <a:t>68/68</a:t>
+                        <a:t>80/80</a:t>
                       </a:r>
                     </a:p>
                   </a:txBody>
@@ -8214,7 +8238,7 @@
                             <a:srgbClr val="242424"/>
                           </a:solidFill>
                         </a:rPr>
-                        <a:t>129/129</a:t>
+                        <a:t>156/156</a:t>
                       </a:r>
                     </a:p>
                   </a:txBody>
@@ -8260,7 +8284,7 @@
                             <a:srgbClr val="242424"/>
                           </a:solidFill>
                         </a:rPr>
-                        <a:t>111/111</a:t>
+                        <a:t>143/143</a:t>
                       </a:r>
                     </a:p>
                   </a:txBody>
@@ -8306,7 +8330,7 @@
                             <a:srgbClr val="242424"/>
                           </a:solidFill>
                         </a:rPr>
-                        <a:t>156/156</a:t>
+                        <a:t>182/182</a:t>
                       </a:r>
                     </a:p>
                   </a:txBody>
@@ -8352,7 +8376,7 @@
                             <a:srgbClr val="242424"/>
                           </a:solidFill>
                         </a:rPr>
-                        <a:t>61/61</a:t>
+                        <a:t>79/79</a:t>
                       </a:r>
                     </a:p>
                   </a:txBody>
@@ -8398,7 +8422,7 @@
                             <a:srgbClr val="242424"/>
                           </a:solidFill>
                         </a:rPr>
-                        <a:t>171/171</a:t>
+                        <a:t>216/216</a:t>
                       </a:r>
                     </a:p>
                   </a:txBody>
@@ -8479,7 +8503,7 @@
                 </a:solidFill>
                 <a:latin typeface="Calibri"/>
               </a:rPr>
-              <a:t>Risk rules on 1,000 synthetic claims: precision 86.6%, recall 84.1% (injected patterns only)</a:t>
+              <a:t>Risk rules on 10,000 synthetic claims: precision 90.1%, recall 78.3% (injected patterns only)</a:t>
             </a:r>
           </a:p>
         </p:txBody>
@@ -8586,7 +8610,7 @@
                 </a:solidFill>
                 <a:latin typeface="Calibri"/>
               </a:rPr>
-              <a:t>127 backend tests  ·  12 browser tests  ·  live site checks passed (15 Oct 2026)</a:t>
+              <a:t>158 backend tests  ·  12 browser tests  ·  live site checks passed (30 Oct 2026)</a:t>
             </a:r>
           </a:p>
         </p:txBody>
@@ -8916,7 +8940,7 @@
                 </a:solidFill>
                 <a:latin typeface="Calibri"/>
               </a:rPr>
-              <a:t>A working, deployed claims decision-support system for health, motor, home and travel insurance.</a:t>
+              <a:t>A working, deployed claims decision-support system for health, motor, home, travel, personal accident and life insurance.</a:t>
             </a:r>
           </a:p>
           <a:p>
@@ -8950,7 +8974,7 @@
                 </a:solidFill>
                 <a:latin typeface="Calibri"/>
               </a:rPr>
-              <a:t>Exact, explainable payable amounts: 803/803 hand-worked checks pass, and every step cites its clause.</a:t>
+              <a:t>Exact, explainable payable amounts: 986/986 hand-worked checks pass, and every step cites its clause.</a:t>
             </a:r>
           </a:p>
           <a:p>
@@ -9017,7 +9041,7 @@
                 </a:solidFill>
                 <a:latin typeface="Calibri"/>
               </a:rPr>
-              <a:t>The free hosting tier restarts with the 57 seeded claims, so claims filed on the live site are not kept.</a:t>
+              <a:t>The free hosting tier restarts with the 72 seeded claims, so claims filed on the live site are not kept.</a:t>
             </a:r>
           </a:p>
         </p:txBody>
@@ -9792,11 +9816,11 @@
           <a:p>
             <a:pPr algn="l">
               <a:spcAft>
-                <a:spcPts val="1000"/>
-              </a:spcAft>
-            </a:pPr>
-            <a:r>
-              <a:rPr sz="1500" b="0" i="0">
+                <a:spcPts val="800"/>
+              </a:spcAft>
+            </a:pPr>
+            <a:r>
+              <a:rPr sz="1400" b="0" i="0">
                 <a:solidFill>
                   <a:srgbClr val="242424"/>
                 </a:solidFill>
@@ -9808,11 +9832,11 @@
           <a:p>
             <a:pPr algn="l">
               <a:spcAft>
-                <a:spcPts val="1000"/>
-              </a:spcAft>
-            </a:pPr>
-            <a:r>
-              <a:rPr sz="1500" b="0" i="0">
+                <a:spcPts val="800"/>
+              </a:spcAft>
+            </a:pPr>
+            <a:r>
+              <a:rPr sz="1400" b="0" i="0">
                 <a:solidFill>
                   <a:srgbClr val="242424"/>
                 </a:solidFill>
@@ -9824,11 +9848,11 @@
           <a:p>
             <a:pPr algn="l">
               <a:spcAft>
-                <a:spcPts val="1000"/>
-              </a:spcAft>
-            </a:pPr>
-            <a:r>
-              <a:rPr sz="1500" b="0" i="0">
+                <a:spcPts val="800"/>
+              </a:spcAft>
+            </a:pPr>
+            <a:r>
+              <a:rPr sz="1400" b="0" i="0">
                 <a:solidFill>
                   <a:srgbClr val="242424"/>
                 </a:solidFill>
@@ -9840,11 +9864,11 @@
           <a:p>
             <a:pPr algn="l">
               <a:spcAft>
-                <a:spcPts val="1000"/>
-              </a:spcAft>
-            </a:pPr>
-            <a:r>
-              <a:rPr sz="1500" b="0" i="0">
+                <a:spcPts val="800"/>
+              </a:spcAft>
+            </a:pPr>
+            <a:r>
+              <a:rPr sz="1400" b="0" i="0">
                 <a:solidFill>
                   <a:srgbClr val="242424"/>
                 </a:solidFill>
@@ -9856,33 +9880,49 @@
           <a:p>
             <a:pPr algn="l">
               <a:spcAft>
-                <a:spcPts val="1000"/>
-              </a:spcAft>
-            </a:pPr>
-            <a:r>
-              <a:rPr sz="1500" b="0" i="0">
+                <a:spcPts val="800"/>
+              </a:spcAft>
+            </a:pPr>
+            <a:r>
+              <a:rPr sz="1400" b="0" i="0">
                 <a:solidFill>
                   <a:srgbClr val="242424"/>
                 </a:solidFill>
                 <a:latin typeface="Calibri"/>
               </a:rPr>
-              <a:t>[5]  FastAPI documentation, https://fastapi.tiangolo.com  ·  React documentation, https://react.dev  ·  SQLAlchemy documentation, https://www.sqlalchemy.org</a:t>
+              <a:t>[5]  Casualty Actuarial Society, Loss Reserving Data Pulled From NAIC Schedule P (accident years 1998-2007), compiled for the CAS by S&amp;P Global Market Intelligence. https://www.casact.org</a:t>
             </a:r>
           </a:p>
           <a:p>
             <a:pPr algn="l">
               <a:spcAft>
-                <a:spcPts val="1000"/>
-              </a:spcAft>
-            </a:pPr>
-            <a:r>
-              <a:rPr sz="1500" b="0" i="0">
+                <a:spcPts val="800"/>
+              </a:spcAft>
+            </a:pPr>
+            <a:r>
+              <a:rPr sz="1400" b="0" i="0">
                 <a:solidFill>
                   <a:srgbClr val="242424"/>
                 </a:solidFill>
                 <a:latin typeface="Calibri"/>
               </a:rPr>
-              <a:t>[6]  Project source code: https://github.com/sricharansk/CLAIM-SENSE  ·  Live application: https://claim-sense.onrender.com</a:t>
+              <a:t>[6]  FastAPI documentation, https://fastapi.tiangolo.com  ·  React documentation, https://react.dev  ·  SQLAlchemy documentation, https://www.sqlalchemy.org</a:t>
+            </a:r>
+          </a:p>
+          <a:p>
+            <a:pPr algn="l">
+              <a:spcAft>
+                <a:spcPts val="800"/>
+              </a:spcAft>
+            </a:pPr>
+            <a:r>
+              <a:rPr sz="1400" b="0" i="0">
+                <a:solidFill>
+                  <a:srgbClr val="242424"/>
+                </a:solidFill>
+                <a:latin typeface="Calibri"/>
+              </a:rPr>
+              <a:t>[7]  Project source code: https://github.com/sricharansk/CLAIM-SENSE  ·  Live application: https://claim-sense.onrender.com</a:t>
             </a:r>
           </a:p>
         </p:txBody>
@@ -10387,7 +10427,7 @@
                 </a:solidFill>
                 <a:latin typeface="Calibri"/>
               </a:rPr>
-              <a:t>4</a:t>
+              <a:t>6</a:t>
             </a:r>
           </a:p>
         </p:txBody>
@@ -10426,7 +10466,7 @@
                 </a:solidFill>
                 <a:latin typeface="Calibri"/>
               </a:rPr>
-              <a:t>lines of business: health, motor, home and travel</a:t>
+              <a:t>lines: health, motor, home, travel, personal accident, life</a:t>
             </a:r>
           </a:p>
         </p:txBody>
@@ -10635,7 +10675,7 @@
                 </a:solidFill>
                 <a:latin typeface="Calibri"/>
               </a:rPr>
-              <a:t>58</a:t>
+              <a:t>72</a:t>
             </a:r>
           </a:p>
         </p:txBody>
@@ -12505,7 +12545,7 @@
                 </a:solidFill>
                 <a:latin typeface="Calibri"/>
               </a:rPr>
-              <a:t>Each document is classified (11 types: discharge summary, repair estimate, surveyor loss assessment, airline report ...).</a:t>
+              <a:t>Each document is classified (14 types: discharge summary, repair estimate, loss assessment, death certificate ...).</a:t>
             </a:r>
           </a:p>
           <a:p>
@@ -13734,7 +13774,7 @@
                 </a:solidFill>
                 <a:latin typeface="Calibri"/>
               </a:rPr>
-              <a:t>Home: contents depreciation, the average clause for underinsurance (15% tolerance), excess.</a:t>
+              <a:t>Home: depreciation and the average clause for underinsurance; travel: per-item and per-benefit limits.</a:t>
             </a:r>
           </a:p>
           <a:p>
@@ -13751,7 +13791,7 @@
                 </a:solidFill>
                 <a:latin typeface="Calibri"/>
               </a:rPr>
-              <a:t>Travel: per-item and per-benefit limits, personal comfort items excluded, deductible.</a:t>
+              <a:t>Personal accident and life: a benefit schedule (% of the capital sum insured) and the sum assured.</a:t>
             </a:r>
           </a:p>
           <a:p>
@@ -14306,7 +14346,7 @@
                 </a:solidFill>
                 <a:latin typeface="Calibri"/>
               </a:rPr>
-              <a:t>Rule-based risk score: duplicate, early claim, high amount ratio, amount mismatch, name mismatch, missing documents.</a:t>
+              <a:t>Rule-based risk score: duplicate, early claim, high amount ratio, amount or name mismatch, missing documents, life contestable period.</a:t>
             </a:r>
           </a:p>
           <a:p>
@@ -16904,7 +16944,7 @@
                 </a:solidFill>
                 <a:latin typeface="Calibri"/>
               </a:rPr>
-              <a:t>5 wordings + structured terms, PDF ingestion</a:t>
+              <a:t>7 wordings + structured terms, PDF ingestion</a:t>
             </a:r>
           </a:p>
         </p:txBody>

</xml_diff>